<commit_message>
Update data files, instructor notebooks, and slide decks
Co-Authored-By: Claude Opus 4.6 <noreply@anthropic.com>
</commit_message>
<xml_diff>
--- a/Slides/00 - Intro_Admin.pptx
+++ b/Slides/00 - Intro_Admin.pptx
@@ -146,35 +146,20 @@
 <file path=ppt/changesInfos/changesInfo1.xml><?xml version="1.0" encoding="utf-8"?>
 <pc:chgInfo xmlns:a="http://schemas.openxmlformats.org/drawingml/2006/main" xmlns:r="http://schemas.openxmlformats.org/officeDocument/2006/relationships" xmlns:ac="http://schemas.microsoft.com/office/drawing/2013/main/command" xmlns:pc="http://schemas.microsoft.com/office/powerpoint/2013/main/command">
   <pc:docChgLst>
-    <pc:chgData name="PAMILAGAS, KEVIN S CTR USAF AETC AFIT/LSM" userId="009fbf30-8171-4f28-916c-cb4b56e6ee63" providerId="ADAL" clId="{E8BF0AA5-E1AB-439F-9F39-2DFCC22BD826}"/>
+    <pc:chgData name="Kevin Pamilagas" userId="95fbd0607220e462" providerId="LiveId" clId="{5BB3BEA8-DB17-46A8-B2F7-5EC3E1D3DA39}"/>
     <pc:docChg chg="modSld">
-      <pc:chgData name="PAMILAGAS, KEVIN S CTR USAF AETC AFIT/LSM" userId="009fbf30-8171-4f28-916c-cb4b56e6ee63" providerId="ADAL" clId="{E8BF0AA5-E1AB-439F-9F39-2DFCC22BD826}" dt="2025-12-19T17:32:04.377" v="93" actId="20577"/>
+      <pc:chgData name="Kevin Pamilagas" userId="95fbd0607220e462" providerId="LiveId" clId="{5BB3BEA8-DB17-46A8-B2F7-5EC3E1D3DA39}" dt="2026-03-06T17:20:18.502" v="74" actId="20577"/>
       <pc:docMkLst>
         <pc:docMk/>
       </pc:docMkLst>
       <pc:sldChg chg="modSp mod">
-        <pc:chgData name="PAMILAGAS, KEVIN S CTR USAF AETC AFIT/LSM" userId="009fbf30-8171-4f28-916c-cb4b56e6ee63" providerId="ADAL" clId="{E8BF0AA5-E1AB-439F-9F39-2DFCC22BD826}" dt="2025-12-15T13:50:43.763" v="0" actId="20577"/>
-        <pc:sldMkLst>
-          <pc:docMk/>
-          <pc:sldMk cId="1200624107" sldId="256"/>
-        </pc:sldMkLst>
-        <pc:spChg chg="mod">
-          <ac:chgData name="PAMILAGAS, KEVIN S CTR USAF AETC AFIT/LSM" userId="009fbf30-8171-4f28-916c-cb4b56e6ee63" providerId="ADAL" clId="{E8BF0AA5-E1AB-439F-9F39-2DFCC22BD826}" dt="2025-12-15T13:50:43.763" v="0" actId="20577"/>
-          <ac:spMkLst>
-            <pc:docMk/>
-            <pc:sldMk cId="1200624107" sldId="256"/>
-            <ac:spMk id="6" creationId="{00000000-0000-0000-0000-000000000000}"/>
-          </ac:spMkLst>
-        </pc:spChg>
-      </pc:sldChg>
-      <pc:sldChg chg="modSp mod">
-        <pc:chgData name="PAMILAGAS, KEVIN S CTR USAF AETC AFIT/LSM" userId="009fbf30-8171-4f28-916c-cb4b56e6ee63" providerId="ADAL" clId="{E8BF0AA5-E1AB-439F-9F39-2DFCC22BD826}" dt="2025-12-19T17:32:04.377" v="93" actId="20577"/>
+        <pc:chgData name="Kevin Pamilagas" userId="95fbd0607220e462" providerId="LiveId" clId="{5BB3BEA8-DB17-46A8-B2F7-5EC3E1D3DA39}" dt="2026-03-06T17:20:18.502" v="74" actId="20577"/>
         <pc:sldMkLst>
           <pc:docMk/>
           <pc:sldMk cId="1666906562" sldId="279"/>
         </pc:sldMkLst>
         <pc:spChg chg="mod">
-          <ac:chgData name="PAMILAGAS, KEVIN S CTR USAF AETC AFIT/LSM" userId="009fbf30-8171-4f28-916c-cb4b56e6ee63" providerId="ADAL" clId="{E8BF0AA5-E1AB-439F-9F39-2DFCC22BD826}" dt="2025-12-19T13:38:34.170" v="78" actId="20577"/>
+          <ac:chgData name="Kevin Pamilagas" userId="95fbd0607220e462" providerId="LiveId" clId="{5BB3BEA8-DB17-46A8-B2F7-5EC3E1D3DA39}" dt="2026-03-06T13:52:54.204" v="58" actId="20577"/>
           <ac:spMkLst>
             <pc:docMk/>
             <pc:sldMk cId="1666906562" sldId="279"/>
@@ -182,7 +167,7 @@
           </ac:spMkLst>
         </pc:spChg>
         <pc:spChg chg="mod">
-          <ac:chgData name="PAMILAGAS, KEVIN S CTR USAF AETC AFIT/LSM" userId="009fbf30-8171-4f28-916c-cb4b56e6ee63" providerId="ADAL" clId="{E8BF0AA5-E1AB-439F-9F39-2DFCC22BD826}" dt="2025-12-19T17:32:04.377" v="93" actId="20577"/>
+          <ac:chgData name="Kevin Pamilagas" userId="95fbd0607220e462" providerId="LiveId" clId="{5BB3BEA8-DB17-46A8-B2F7-5EC3E1D3DA39}" dt="2026-03-06T17:20:18.502" v="74" actId="20577"/>
           <ac:spMkLst>
             <pc:docMk/>
             <pc:sldMk cId="1666906562" sldId="279"/>
@@ -310,7 +295,7 @@
           <a:p>
             <a:fld id="{45339156-D567-496F-8C1B-A0D27A63BC14}" type="datetimeFigureOut">
               <a:rPr lang="en-US" smtClean="0"/>
-              <a:t>12/19/2025</a:t>
+              <a:t>3/5/2026</a:t>
             </a:fld>
             <a:endParaRPr lang="en-US"/>
           </a:p>
@@ -2259,7 +2244,7 @@
           <a:p>
             <a:fld id="{DE5CB39B-8E5F-485E-A282-592B276E07F9}" type="datetimeFigureOut">
               <a:rPr lang="en-US" smtClean="0"/>
-              <a:t>12/19/2025</a:t>
+              <a:t>3/5/2026</a:t>
             </a:fld>
             <a:endParaRPr lang="en-US"/>
           </a:p>
@@ -2435,7 +2420,7 @@
           <a:p>
             <a:fld id="{DE5CB39B-8E5F-485E-A282-592B276E07F9}" type="datetimeFigureOut">
               <a:rPr lang="en-US" smtClean="0"/>
-              <a:t>12/19/2025</a:t>
+              <a:t>3/5/2026</a:t>
             </a:fld>
             <a:endParaRPr lang="en-US"/>
           </a:p>
@@ -2613,7 +2598,7 @@
           <a:p>
             <a:fld id="{DE5CB39B-8E5F-485E-A282-592B276E07F9}" type="datetimeFigureOut">
               <a:rPr lang="en-US" smtClean="0"/>
-              <a:t>12/19/2025</a:t>
+              <a:t>3/5/2026</a:t>
             </a:fld>
             <a:endParaRPr lang="en-US"/>
           </a:p>
@@ -2783,7 +2768,7 @@
           <a:p>
             <a:fld id="{DE5CB39B-8E5F-485E-A282-592B276E07F9}" type="datetimeFigureOut">
               <a:rPr lang="en-US" smtClean="0"/>
-              <a:t>12/19/2025</a:t>
+              <a:t>3/5/2026</a:t>
             </a:fld>
             <a:endParaRPr lang="en-US"/>
           </a:p>
@@ -3029,7 +3014,7 @@
           <a:p>
             <a:fld id="{DE5CB39B-8E5F-485E-A282-592B276E07F9}" type="datetimeFigureOut">
               <a:rPr lang="en-US" smtClean="0"/>
-              <a:t>12/19/2025</a:t>
+              <a:t>3/5/2026</a:t>
             </a:fld>
             <a:endParaRPr lang="en-US"/>
           </a:p>
@@ -3315,7 +3300,7 @@
           <a:p>
             <a:fld id="{DE5CB39B-8E5F-485E-A282-592B276E07F9}" type="datetimeFigureOut">
               <a:rPr lang="en-US" smtClean="0"/>
-              <a:t>12/19/2025</a:t>
+              <a:t>3/5/2026</a:t>
             </a:fld>
             <a:endParaRPr lang="en-US"/>
           </a:p>
@@ -3735,7 +3720,7 @@
           <a:p>
             <a:fld id="{DE5CB39B-8E5F-485E-A282-592B276E07F9}" type="datetimeFigureOut">
               <a:rPr lang="en-US" smtClean="0"/>
-              <a:t>12/19/2025</a:t>
+              <a:t>3/5/2026</a:t>
             </a:fld>
             <a:endParaRPr lang="en-US"/>
           </a:p>
@@ -3857,7 +3842,7 @@
           <a:p>
             <a:fld id="{DE5CB39B-8E5F-485E-A282-592B276E07F9}" type="datetimeFigureOut">
               <a:rPr lang="en-US" smtClean="0"/>
-              <a:t>12/19/2025</a:t>
+              <a:t>3/5/2026</a:t>
             </a:fld>
             <a:endParaRPr lang="en-US"/>
           </a:p>
@@ -3952,7 +3937,7 @@
           <a:p>
             <a:fld id="{DE5CB39B-8E5F-485E-A282-592B276E07F9}" type="datetimeFigureOut">
               <a:rPr lang="en-US" smtClean="0"/>
-              <a:t>12/19/2025</a:t>
+              <a:t>3/5/2026</a:t>
             </a:fld>
             <a:endParaRPr lang="en-US"/>
           </a:p>
@@ -4229,7 +4214,7 @@
           <a:p>
             <a:fld id="{DE5CB39B-8E5F-485E-A282-592B276E07F9}" type="datetimeFigureOut">
               <a:rPr lang="en-US" smtClean="0"/>
-              <a:t>12/19/2025</a:t>
+              <a:t>3/5/2026</a:t>
             </a:fld>
             <a:endParaRPr lang="en-US"/>
           </a:p>
@@ -4484,7 +4469,7 @@
           <a:p>
             <a:fld id="{DE5CB39B-8E5F-485E-A282-592B276E07F9}" type="datetimeFigureOut">
               <a:rPr lang="en-US" smtClean="0"/>
-              <a:t>12/19/2025</a:t>
+              <a:t>3/5/2026</a:t>
             </a:fld>
             <a:endParaRPr lang="en-US"/>
           </a:p>
@@ -4955,7 +4940,7 @@
           <a:p>
             <a:fld id="{DE5CB39B-8E5F-485E-A282-592B276E07F9}" type="datetimeFigureOut">
               <a:rPr lang="en-US" smtClean="0"/>
-              <a:t>12/19/2025</a:t>
+              <a:t>3/5/2026</a:t>
             </a:fld>
             <a:endParaRPr lang="en-US"/>
           </a:p>
@@ -6656,7 +6641,7 @@
                 <a:ea typeface="+mn-ea"/>
                 <a:cs typeface="+mn-cs"/>
               </a:rPr>
-              <a:t>        RESUME: </a:t>
+              <a:t>        RESUME: 1230</a:t>
             </a:r>
             <a:r>
               <a:rPr lang="en-US" sz="3600" b="1" dirty="0">
@@ -6667,7 +6652,7 @@
                 </a:solidFill>
                 <a:latin typeface="Calibri"/>
               </a:rPr>
-              <a:t>1240 </a:t>
+              <a:t> </a:t>
             </a:r>
             <a:r>
               <a:rPr kumimoji="0" lang="en-US" sz="3600" b="1" i="0" u="none" strike="noStrike" kern="1200" cap="none" spc="0" normalizeH="0" baseline="0" noProof="0" dirty="0">
@@ -8779,17 +8764,6 @@
 </file>
 
 <file path=customXml/item1.xml><?xml version="1.0" encoding="utf-8"?>
-<p:properties xmlns:p="http://schemas.microsoft.com/office/2006/metadata/properties" xmlns:xsi="http://www.w3.org/2001/XMLSchema-instance" xmlns:pc="http://schemas.microsoft.com/office/infopath/2007/PartnerControls">
-  <documentManagement>
-    <TaxCatchAll xmlns="90685ef0-b1b4-458c-829f-f398f8759114" xsi:nil="true"/>
-    <lcf76f155ced4ddcb4097134ff3c332f xmlns="642e82f0-cb46-4fb4-8075-6238c0cf1caf">
-      <Terms xmlns="http://schemas.microsoft.com/office/infopath/2007/PartnerControls"/>
-    </lcf76f155ced4ddcb4097134ff3c332f>
-  </documentManagement>
-</p:properties>
-</file>
-
-<file path=customXml/item2.xml><?xml version="1.0" encoding="utf-8"?>
 <?mso-contentType ?>
 <FormTemplates xmlns="http://schemas.microsoft.com/sharepoint/v3/contenttype/forms">
   <Display>DocumentLibraryForm</Display>
@@ -8798,7 +8772,7 @@
 </FormTemplates>
 </file>
 
-<file path=customXml/item3.xml><?xml version="1.0" encoding="utf-8"?>
+<file path=customXml/item2.xml><?xml version="1.0" encoding="utf-8"?>
 <ct:contentTypeSchema xmlns:ct="http://schemas.microsoft.com/office/2006/metadata/contentType" xmlns:ma="http://schemas.microsoft.com/office/2006/metadata/properties/metaAttributes" ct:_="" ma:_="" ma:contentTypeName="Document" ma:contentTypeID="0x0101009EC9433B644E604094407ACD1E5072B8" ma:contentTypeVersion="11" ma:contentTypeDescription="Create a new document." ma:contentTypeScope="" ma:versionID="3d1b3dfc843b4f81bcd91a66cd11289c">
   <xsd:schema xmlns:xsd="http://www.w3.org/2001/XMLSchema" xmlns:xs="http://www.w3.org/2001/XMLSchema" xmlns:p="http://schemas.microsoft.com/office/2006/metadata/properties" xmlns:ns2="642e82f0-cb46-4fb4-8075-6238c0cf1caf" xmlns:ns3="90685ef0-b1b4-458c-829f-f398f8759114" targetNamespace="http://schemas.microsoft.com/office/2006/metadata/properties" ma:root="true" ma:fieldsID="c2c5bc462af54d3217fc1b623fd434e4" ns2:_="" ns3:_="">
     <xsd:import namespace="642e82f0-cb46-4fb4-8075-6238c0cf1caf"/>
@@ -8993,20 +8967,18 @@
 </ct:contentTypeSchema>
 </file>
 
-<file path=customXml/itemProps1.xml><?xml version="1.0" encoding="utf-8"?>
-<ds:datastoreItem xmlns:ds="http://schemas.openxmlformats.org/officeDocument/2006/customXml" ds:itemID="{788B5E7D-9C02-44FA-96B3-2BC0EDBB49E2}">
-  <ds:schemaRefs>
-    <ds:schemaRef ds:uri="http://schemas.microsoft.com/office/2006/metadata/properties"/>
-    <ds:schemaRef ds:uri="http://schemas.microsoft.com/office/infopath/2007/PartnerControls"/>
-    <ds:schemaRef ds:uri="30d97937-01a3-4de3-90ca-5e7d330c9e3c"/>
-    <ds:schemaRef ds:uri="9424389c-3462-41f7-a219-8f9753f44d22"/>
-    <ds:schemaRef ds:uri="90685ef0-b1b4-458c-829f-f398f8759114"/>
-    <ds:schemaRef ds:uri="642e82f0-cb46-4fb4-8075-6238c0cf1caf"/>
-  </ds:schemaRefs>
-</ds:datastoreItem>
+<file path=customXml/item3.xml><?xml version="1.0" encoding="utf-8"?>
+<p:properties xmlns:p="http://schemas.microsoft.com/office/2006/metadata/properties" xmlns:xsi="http://www.w3.org/2001/XMLSchema-instance" xmlns:pc="http://schemas.microsoft.com/office/infopath/2007/PartnerControls">
+  <documentManagement>
+    <TaxCatchAll xmlns="90685ef0-b1b4-458c-829f-f398f8759114" xsi:nil="true"/>
+    <lcf76f155ced4ddcb4097134ff3c332f xmlns="642e82f0-cb46-4fb4-8075-6238c0cf1caf">
+      <Terms xmlns="http://schemas.microsoft.com/office/infopath/2007/PartnerControls"/>
+    </lcf76f155ced4ddcb4097134ff3c332f>
+  </documentManagement>
+</p:properties>
 </file>
 
-<file path=customXml/itemProps2.xml><?xml version="1.0" encoding="utf-8"?>
+<file path=customXml/itemProps1.xml><?xml version="1.0" encoding="utf-8"?>
 <ds:datastoreItem xmlns:ds="http://schemas.openxmlformats.org/officeDocument/2006/customXml" ds:itemID="{F8CF3EDC-8FD0-4596-81B6-38CE81E1E856}">
   <ds:schemaRefs>
     <ds:schemaRef ds:uri="http://schemas.microsoft.com/sharepoint/v3/contenttype/forms"/>
@@ -9014,7 +8986,7 @@
 </ds:datastoreItem>
 </file>
 
-<file path=customXml/itemProps3.xml><?xml version="1.0" encoding="utf-8"?>
+<file path=customXml/itemProps2.xml><?xml version="1.0" encoding="utf-8"?>
 <ds:datastoreItem xmlns:ds="http://schemas.openxmlformats.org/officeDocument/2006/customXml" ds:itemID="{3298221C-B78A-47B7-BF46-B98F710577AA}">
   <ds:schemaRefs>
     <ds:schemaRef ds:uri="http://schemas.microsoft.com/office/2006/metadata/contentType"/>
@@ -9031,4 +9003,17 @@
     <ds:schemaRef ds:uri="http://schemas.microsoft.com/internal/obd"/>
   </ds:schemaRefs>
 </ds:datastoreItem>
+</file>
+
+<file path=customXml/itemProps3.xml><?xml version="1.0" encoding="utf-8"?>
+<ds:datastoreItem xmlns:ds="http://schemas.openxmlformats.org/officeDocument/2006/customXml" ds:itemID="{788B5E7D-9C02-44FA-96B3-2BC0EDBB49E2}">
+  <ds:schemaRefs>
+    <ds:schemaRef ds:uri="http://schemas.microsoft.com/office/2006/metadata/properties"/>
+    <ds:schemaRef ds:uri="http://schemas.microsoft.com/office/infopath/2007/PartnerControls"/>
+    <ds:schemaRef ds:uri="30d97937-01a3-4de3-90ca-5e7d330c9e3c"/>
+    <ds:schemaRef ds:uri="9424389c-3462-41f7-a219-8f9753f44d22"/>
+    <ds:schemaRef ds:uri="90685ef0-b1b4-458c-829f-f398f8759114"/>
+    <ds:schemaRef ds:uri="642e82f0-cb46-4fb4-8075-6238c0cf1caf"/>
+  </ds:schemaRefs>
+</ds:datastoreItem>
 </file>
</xml_diff>

<commit_message>
Update Intro/Admin slide deck
Co-Authored-By: Claude Opus 4.6 <noreply@anthropic.com>
</commit_message>
<xml_diff>
--- a/Slides/00 - Intro_Admin.pptx
+++ b/Slides/00 - Intro_Admin.pptx
@@ -5,10 +5,10 @@
     <p:sldMasterId id="2147483672" r:id="rId4"/>
   </p:sldMasterIdLst>
   <p:notesMasterIdLst>
-    <p:notesMasterId r:id="rId25"/>
+    <p:notesMasterId r:id="rId26"/>
   </p:notesMasterIdLst>
   <p:handoutMasterIdLst>
-    <p:handoutMasterId r:id="rId26"/>
+    <p:handoutMasterId r:id="rId27"/>
   </p:handoutMasterIdLst>
   <p:sldIdLst>
     <p:sldId id="256" r:id="rId5"/>
@@ -20,22 +20,23 @@
     <p:sldId id="280" r:id="rId11"/>
     <p:sldId id="264" r:id="rId12"/>
     <p:sldId id="282" r:id="rId13"/>
-    <p:sldId id="276" r:id="rId14"/>
-    <p:sldId id="281" r:id="rId15"/>
-    <p:sldId id="265" r:id="rId16"/>
-    <p:sldId id="266" r:id="rId17"/>
-    <p:sldId id="258" r:id="rId18"/>
-    <p:sldId id="259" r:id="rId19"/>
-    <p:sldId id="260" r:id="rId20"/>
-    <p:sldId id="261" r:id="rId21"/>
-    <p:sldId id="268" r:id="rId22"/>
-    <p:sldId id="262" r:id="rId23"/>
-    <p:sldId id="263" r:id="rId24"/>
+    <p:sldId id="283" r:id="rId14"/>
+    <p:sldId id="276" r:id="rId15"/>
+    <p:sldId id="281" r:id="rId16"/>
+    <p:sldId id="265" r:id="rId17"/>
+    <p:sldId id="266" r:id="rId18"/>
+    <p:sldId id="258" r:id="rId19"/>
+    <p:sldId id="259" r:id="rId20"/>
+    <p:sldId id="260" r:id="rId21"/>
+    <p:sldId id="261" r:id="rId22"/>
+    <p:sldId id="268" r:id="rId23"/>
+    <p:sldId id="262" r:id="rId24"/>
+    <p:sldId id="263" r:id="rId25"/>
   </p:sldIdLst>
   <p:sldSz cx="9144000" cy="6858000" type="screen4x3"/>
   <p:notesSz cx="7315200" cy="9601200"/>
   <p:custDataLst>
-    <p:tags r:id="rId27"/>
+    <p:tags r:id="rId28"/>
   </p:custDataLst>
   <p:defaultTextStyle>
     <a:defPPr>
@@ -143,15 +144,69 @@
 </p:presentation>
 </file>
 
+<file path=ppt/revisionInfo.xml><?xml version="1.0" encoding="utf-8"?>
+<p1510:revInfo xmlns:a="http://schemas.openxmlformats.org/drawingml/2006/main" xmlns:r="http://schemas.openxmlformats.org/officeDocument/2006/relationships" xmlns:p1510="http://schemas.microsoft.com/office/powerpoint/2015/10/main">
+  <p1510:revLst>
+    <p1510:client id="{9A575BE6-A855-42B2-94FD-00584F87B999}" v="20" dt="2026-03-17T17:13:22.006"/>
+  </p1510:revLst>
+</p1510:revInfo>
+</file>
+
 <file path=ppt/changesInfos/changesInfo1.xml><?xml version="1.0" encoding="utf-8"?>
 <pc:chgInfo xmlns:a="http://schemas.openxmlformats.org/drawingml/2006/main" xmlns:r="http://schemas.openxmlformats.org/officeDocument/2006/relationships" xmlns:ac="http://schemas.microsoft.com/office/drawing/2013/main/command" xmlns:pc="http://schemas.microsoft.com/office/powerpoint/2013/main/command">
   <pc:docChgLst>
     <pc:chgData name="Kevin Pamilagas" userId="95fbd0607220e462" providerId="LiveId" clId="{5BB3BEA8-DB17-46A8-B2F7-5EC3E1D3DA39}"/>
-    <pc:docChg chg="modSld">
-      <pc:chgData name="Kevin Pamilagas" userId="95fbd0607220e462" providerId="LiveId" clId="{5BB3BEA8-DB17-46A8-B2F7-5EC3E1D3DA39}" dt="2026-03-06T17:20:18.502" v="74" actId="20577"/>
+    <pc:docChg chg="custSel addSld modSld">
+      <pc:chgData name="Kevin Pamilagas" userId="95fbd0607220e462" providerId="LiveId" clId="{5BB3BEA8-DB17-46A8-B2F7-5EC3E1D3DA39}" dt="2026-03-17T17:14:27.405" v="160" actId="20577"/>
       <pc:docMkLst>
         <pc:docMk/>
       </pc:docMkLst>
+      <pc:sldChg chg="modSp mod">
+        <pc:chgData name="Kevin Pamilagas" userId="95fbd0607220e462" providerId="LiveId" clId="{5BB3BEA8-DB17-46A8-B2F7-5EC3E1D3DA39}" dt="2026-03-17T17:14:27.405" v="160" actId="20577"/>
+        <pc:sldMkLst>
+          <pc:docMk/>
+          <pc:sldMk cId="674039978" sldId="268"/>
+        </pc:sldMkLst>
+        <pc:spChg chg="mod">
+          <ac:chgData name="Kevin Pamilagas" userId="95fbd0607220e462" providerId="LiveId" clId="{5BB3BEA8-DB17-46A8-B2F7-5EC3E1D3DA39}" dt="2026-03-17T17:14:27.405" v="160" actId="20577"/>
+          <ac:spMkLst>
+            <pc:docMk/>
+            <pc:sldMk cId="674039978" sldId="268"/>
+            <ac:spMk id="3" creationId="{00000000-0000-0000-0000-000000000000}"/>
+          </ac:spMkLst>
+        </pc:spChg>
+      </pc:sldChg>
+      <pc:sldChg chg="addSp delSp modSp mod">
+        <pc:chgData name="Kevin Pamilagas" userId="95fbd0607220e462" providerId="LiveId" clId="{5BB3BEA8-DB17-46A8-B2F7-5EC3E1D3DA39}" dt="2026-03-17T17:10:36.513" v="84" actId="1076"/>
+        <pc:sldMkLst>
+          <pc:docMk/>
+          <pc:sldMk cId="2531377879" sldId="276"/>
+        </pc:sldMkLst>
+        <pc:picChg chg="add del mod">
+          <ac:chgData name="Kevin Pamilagas" userId="95fbd0607220e462" providerId="LiveId" clId="{5BB3BEA8-DB17-46A8-B2F7-5EC3E1D3DA39}" dt="2026-03-17T17:10:29.312" v="82" actId="478"/>
+          <ac:picMkLst>
+            <pc:docMk/>
+            <pc:sldMk cId="2531377879" sldId="276"/>
+            <ac:picMk id="2" creationId="{4DDCF379-2941-E4CE-4C96-C3ABD9C581CC}"/>
+          </ac:picMkLst>
+        </pc:picChg>
+        <pc:picChg chg="del">
+          <ac:chgData name="Kevin Pamilagas" userId="95fbd0607220e462" providerId="LiveId" clId="{5BB3BEA8-DB17-46A8-B2F7-5EC3E1D3DA39}" dt="2026-03-17T17:09:30.195" v="75" actId="478"/>
+          <ac:picMkLst>
+            <pc:docMk/>
+            <pc:sldMk cId="2531377879" sldId="276"/>
+            <ac:picMk id="3" creationId="{5F9BED00-9EE8-97B3-F1A0-63518422A6DB}"/>
+          </ac:picMkLst>
+        </pc:picChg>
+        <pc:picChg chg="add mod">
+          <ac:chgData name="Kevin Pamilagas" userId="95fbd0607220e462" providerId="LiveId" clId="{5BB3BEA8-DB17-46A8-B2F7-5EC3E1D3DA39}" dt="2026-03-17T17:10:36.513" v="84" actId="1076"/>
+          <ac:picMkLst>
+            <pc:docMk/>
+            <pc:sldMk cId="2531377879" sldId="276"/>
+            <ac:picMk id="4" creationId="{366EDCC8-CDF2-FB69-347E-2381520ADB79}"/>
+          </ac:picMkLst>
+        </pc:picChg>
+      </pc:sldChg>
       <pc:sldChg chg="modSp mod">
         <pc:chgData name="Kevin Pamilagas" userId="95fbd0607220e462" providerId="LiveId" clId="{5BB3BEA8-DB17-46A8-B2F7-5EC3E1D3DA39}" dt="2026-03-06T17:20:18.502" v="74" actId="20577"/>
         <pc:sldMkLst>
@@ -174,6 +229,154 @@
             <ac:spMk id="6" creationId="{00000000-0000-0000-0000-000000000000}"/>
           </ac:spMkLst>
         </pc:spChg>
+      </pc:sldChg>
+      <pc:sldChg chg="modSp mod">
+        <pc:chgData name="Kevin Pamilagas" userId="95fbd0607220e462" providerId="LiveId" clId="{5BB3BEA8-DB17-46A8-B2F7-5EC3E1D3DA39}" dt="2026-03-17T17:13:21.186" v="140" actId="20577"/>
+        <pc:sldMkLst>
+          <pc:docMk/>
+          <pc:sldMk cId="1690589970" sldId="280"/>
+        </pc:sldMkLst>
+        <pc:spChg chg="mod">
+          <ac:chgData name="Kevin Pamilagas" userId="95fbd0607220e462" providerId="LiveId" clId="{5BB3BEA8-DB17-46A8-B2F7-5EC3E1D3DA39}" dt="2026-03-17T17:13:21.186" v="140" actId="20577"/>
+          <ac:spMkLst>
+            <pc:docMk/>
+            <pc:sldMk cId="1690589970" sldId="280"/>
+            <ac:spMk id="3" creationId="{00000000-0000-0000-0000-000000000000}"/>
+          </ac:spMkLst>
+        </pc:spChg>
+      </pc:sldChg>
+      <pc:sldChg chg="addSp delSp modSp mod">
+        <pc:chgData name="Kevin Pamilagas" userId="95fbd0607220e462" providerId="LiveId" clId="{5BB3BEA8-DB17-46A8-B2F7-5EC3E1D3DA39}" dt="2026-03-17T17:10:46.002" v="86"/>
+        <pc:sldMkLst>
+          <pc:docMk/>
+          <pc:sldMk cId="1757098653" sldId="281"/>
+        </pc:sldMkLst>
+        <pc:spChg chg="del">
+          <ac:chgData name="Kevin Pamilagas" userId="95fbd0607220e462" providerId="LiveId" clId="{5BB3BEA8-DB17-46A8-B2F7-5EC3E1D3DA39}" dt="2026-03-17T17:10:01.892" v="79" actId="478"/>
+          <ac:spMkLst>
+            <pc:docMk/>
+            <pc:sldMk cId="1757098653" sldId="281"/>
+            <ac:spMk id="3" creationId="{00000000-0000-0000-0000-000000000000}"/>
+          </ac:spMkLst>
+        </pc:spChg>
+        <pc:graphicFrameChg chg="add mod">
+          <ac:chgData name="Kevin Pamilagas" userId="95fbd0607220e462" providerId="LiveId" clId="{5BB3BEA8-DB17-46A8-B2F7-5EC3E1D3DA39}" dt="2026-03-17T17:10:03.599" v="80"/>
+          <ac:graphicFrameMkLst>
+            <pc:docMk/>
+            <pc:sldMk cId="1757098653" sldId="281"/>
+            <ac:graphicFrameMk id="4" creationId="{62B82C1E-FD59-13F6-EE0E-FB0C0EADDCE1}"/>
+          </ac:graphicFrameMkLst>
+        </pc:graphicFrameChg>
+        <pc:picChg chg="del">
+          <ac:chgData name="Kevin Pamilagas" userId="95fbd0607220e462" providerId="LiveId" clId="{5BB3BEA8-DB17-46A8-B2F7-5EC3E1D3DA39}" dt="2026-03-17T17:09:48.197" v="78" actId="478"/>
+          <ac:picMkLst>
+            <pc:docMk/>
+            <pc:sldMk cId="1757098653" sldId="281"/>
+            <ac:picMk id="2" creationId="{7CAC2639-A430-756D-9695-B1D8994D6E72}"/>
+          </ac:picMkLst>
+        </pc:picChg>
+        <pc:picChg chg="add del">
+          <ac:chgData name="Kevin Pamilagas" userId="95fbd0607220e462" providerId="LiveId" clId="{5BB3BEA8-DB17-46A8-B2F7-5EC3E1D3DA39}" dt="2026-03-17T17:10:43.641" v="85" actId="478"/>
+          <ac:picMkLst>
+            <pc:docMk/>
+            <pc:sldMk cId="1757098653" sldId="281"/>
+            <ac:picMk id="5" creationId="{10882B89-34D8-3B1D-929D-63ED9F86589E}"/>
+          </ac:picMkLst>
+        </pc:picChg>
+        <pc:picChg chg="add">
+          <ac:chgData name="Kevin Pamilagas" userId="95fbd0607220e462" providerId="LiveId" clId="{5BB3BEA8-DB17-46A8-B2F7-5EC3E1D3DA39}" dt="2026-03-17T17:10:46.002" v="86"/>
+          <ac:picMkLst>
+            <pc:docMk/>
+            <pc:sldMk cId="1757098653" sldId="281"/>
+            <ac:picMk id="6" creationId="{40A90E59-D996-3D4D-D33C-3C680C687C59}"/>
+          </ac:picMkLst>
+        </pc:picChg>
+      </pc:sldChg>
+      <pc:sldChg chg="addSp delSp modSp mod">
+        <pc:chgData name="Kevin Pamilagas" userId="95fbd0607220e462" providerId="LiveId" clId="{5BB3BEA8-DB17-46A8-B2F7-5EC3E1D3DA39}" dt="2026-03-17T17:12:57.362" v="131" actId="21"/>
+        <pc:sldMkLst>
+          <pc:docMk/>
+          <pc:sldMk cId="2140730942" sldId="282"/>
+        </pc:sldMkLst>
+        <pc:graphicFrameChg chg="add mod">
+          <ac:chgData name="Kevin Pamilagas" userId="95fbd0607220e462" providerId="LiveId" clId="{5BB3BEA8-DB17-46A8-B2F7-5EC3E1D3DA39}" dt="2026-03-17T17:11:39.601" v="91"/>
+          <ac:graphicFrameMkLst>
+            <pc:docMk/>
+            <pc:sldMk cId="2140730942" sldId="282"/>
+            <ac:graphicFrameMk id="4" creationId="{602DA6AB-D803-86E5-706A-AEF84227A52D}"/>
+          </ac:graphicFrameMkLst>
+        </pc:graphicFrameChg>
+        <pc:graphicFrameChg chg="add mod">
+          <ac:chgData name="Kevin Pamilagas" userId="95fbd0607220e462" providerId="LiveId" clId="{5BB3BEA8-DB17-46A8-B2F7-5EC3E1D3DA39}" dt="2026-03-17T17:12:23.007" v="97"/>
+          <ac:graphicFrameMkLst>
+            <pc:docMk/>
+            <pc:sldMk cId="2140730942" sldId="282"/>
+            <ac:graphicFrameMk id="6" creationId="{C34CB826-2F6B-BBD4-5D99-74FB67A5AE52}"/>
+          </ac:graphicFrameMkLst>
+        </pc:graphicFrameChg>
+        <pc:picChg chg="del">
+          <ac:chgData name="Kevin Pamilagas" userId="95fbd0607220e462" providerId="LiveId" clId="{5BB3BEA8-DB17-46A8-B2F7-5EC3E1D3DA39}" dt="2026-03-17T17:11:19.917" v="87" actId="478"/>
+          <ac:picMkLst>
+            <pc:docMk/>
+            <pc:sldMk cId="2140730942" sldId="282"/>
+            <ac:picMk id="2" creationId="{D6FC8C0B-8B96-89E3-9A15-141AA5726EC7}"/>
+          </ac:picMkLst>
+        </pc:picChg>
+        <pc:picChg chg="add del">
+          <ac:chgData name="Kevin Pamilagas" userId="95fbd0607220e462" providerId="LiveId" clId="{5BB3BEA8-DB17-46A8-B2F7-5EC3E1D3DA39}" dt="2026-03-17T17:11:31.633" v="90" actId="478"/>
+          <ac:picMkLst>
+            <pc:docMk/>
+            <pc:sldMk cId="2140730942" sldId="282"/>
+            <ac:picMk id="3" creationId="{9E4E3F54-34A5-C75E-85DB-80496469F964}"/>
+          </ac:picMkLst>
+        </pc:picChg>
+        <pc:picChg chg="add mod">
+          <ac:chgData name="Kevin Pamilagas" userId="95fbd0607220e462" providerId="LiveId" clId="{5BB3BEA8-DB17-46A8-B2F7-5EC3E1D3DA39}" dt="2026-03-17T17:11:52.400" v="94" actId="1076"/>
+          <ac:picMkLst>
+            <pc:docMk/>
+            <pc:sldMk cId="2140730942" sldId="282"/>
+            <ac:picMk id="5" creationId="{C189F0C7-740B-2DAF-BA9A-C62F38A44D75}"/>
+          </ac:picMkLst>
+        </pc:picChg>
+        <pc:picChg chg="add del mod">
+          <ac:chgData name="Kevin Pamilagas" userId="95fbd0607220e462" providerId="LiveId" clId="{5BB3BEA8-DB17-46A8-B2F7-5EC3E1D3DA39}" dt="2026-03-17T17:12:57.362" v="131" actId="21"/>
+          <ac:picMkLst>
+            <pc:docMk/>
+            <pc:sldMk cId="2140730942" sldId="282"/>
+            <ac:picMk id="7" creationId="{239C21E0-2056-BDD4-1BBD-CCD72364D862}"/>
+          </ac:picMkLst>
+        </pc:picChg>
+      </pc:sldChg>
+      <pc:sldChg chg="addSp delSp modSp add mod">
+        <pc:chgData name="Kevin Pamilagas" userId="95fbd0607220e462" providerId="LiveId" clId="{5BB3BEA8-DB17-46A8-B2F7-5EC3E1D3DA39}" dt="2026-03-17T17:13:04.879" v="134" actId="1076"/>
+        <pc:sldMkLst>
+          <pc:docMk/>
+          <pc:sldMk cId="1223413549" sldId="283"/>
+        </pc:sldMkLst>
+        <pc:picChg chg="add del">
+          <ac:chgData name="Kevin Pamilagas" userId="95fbd0607220e462" providerId="LiveId" clId="{5BB3BEA8-DB17-46A8-B2F7-5EC3E1D3DA39}" dt="2026-03-17T17:13:00.197" v="132" actId="478"/>
+          <ac:picMkLst>
+            <pc:docMk/>
+            <pc:sldMk cId="1223413549" sldId="283"/>
+            <ac:picMk id="2" creationId="{E52BCA28-6BB7-7CEB-02AE-14AC3BDE1362}"/>
+          </ac:picMkLst>
+        </pc:picChg>
+        <pc:picChg chg="del">
+          <ac:chgData name="Kevin Pamilagas" userId="95fbd0607220e462" providerId="LiveId" clId="{5BB3BEA8-DB17-46A8-B2F7-5EC3E1D3DA39}" dt="2026-03-17T17:11:55.698" v="95" actId="478"/>
+          <ac:picMkLst>
+            <pc:docMk/>
+            <pc:sldMk cId="1223413549" sldId="283"/>
+            <ac:picMk id="3" creationId="{8ACF7045-70FA-4289-F3CE-17D2409BCCBA}"/>
+          </ac:picMkLst>
+        </pc:picChg>
+        <pc:picChg chg="add mod">
+          <ac:chgData name="Kevin Pamilagas" userId="95fbd0607220e462" providerId="LiveId" clId="{5BB3BEA8-DB17-46A8-B2F7-5EC3E1D3DA39}" dt="2026-03-17T17:13:04.879" v="134" actId="1076"/>
+          <ac:picMkLst>
+            <pc:docMk/>
+            <pc:sldMk cId="1223413549" sldId="283"/>
+            <ac:picMk id="7" creationId="{239C21E0-2056-BDD4-1BBD-CCD72364D862}"/>
+          </ac:picMkLst>
+        </pc:picChg>
       </pc:sldChg>
     </pc:docChg>
   </pc:docChgLst>
@@ -295,7 +498,7 @@
           <a:p>
             <a:fld id="{45339156-D567-496F-8C1B-A0D27A63BC14}" type="datetimeFigureOut">
               <a:rPr lang="en-US" smtClean="0"/>
-              <a:t>3/5/2026</a:t>
+              <a:t>3/17/2026</a:t>
             </a:fld>
             <a:endParaRPr lang="en-US"/>
           </a:p>
@@ -711,7 +914,7 @@
           <a:p>
             <a:fld id="{0EF240FC-2CF2-4EB1-8271-F3765CBA0906}" type="slidenum">
               <a:rPr lang="en-US" smtClean="0"/>
-              <a:t>13</a:t>
+              <a:t>14</a:t>
             </a:fld>
             <a:endParaRPr lang="en-US"/>
           </a:p>
@@ -795,7 +998,7 @@
           <a:p>
             <a:fld id="{0EF240FC-2CF2-4EB1-8271-F3765CBA0906}" type="slidenum">
               <a:rPr lang="en-US" smtClean="0"/>
-              <a:t>14</a:t>
+              <a:t>15</a:t>
             </a:fld>
             <a:endParaRPr lang="en-US"/>
           </a:p>
@@ -879,7 +1082,7 @@
           <a:p>
             <a:fld id="{0EF240FC-2CF2-4EB1-8271-F3765CBA0906}" type="slidenum">
               <a:rPr lang="en-US" smtClean="0"/>
-              <a:t>15</a:t>
+              <a:t>16</a:t>
             </a:fld>
             <a:endParaRPr lang="en-US"/>
           </a:p>
@@ -963,7 +1166,7 @@
           <a:p>
             <a:fld id="{0EF240FC-2CF2-4EB1-8271-F3765CBA0906}" type="slidenum">
               <a:rPr lang="en-US" smtClean="0"/>
-              <a:t>16</a:t>
+              <a:t>17</a:t>
             </a:fld>
             <a:endParaRPr lang="en-US"/>
           </a:p>
@@ -1047,7 +1250,7 @@
           <a:p>
             <a:fld id="{0EF240FC-2CF2-4EB1-8271-F3765CBA0906}" type="slidenum">
               <a:rPr lang="en-US" smtClean="0"/>
-              <a:t>17</a:t>
+              <a:t>18</a:t>
             </a:fld>
             <a:endParaRPr lang="en-US"/>
           </a:p>
@@ -1131,7 +1334,7 @@
           <a:p>
             <a:fld id="{0EF240FC-2CF2-4EB1-8271-F3765CBA0906}" type="slidenum">
               <a:rPr lang="en-US" smtClean="0"/>
-              <a:t>18</a:t>
+              <a:t>19</a:t>
             </a:fld>
             <a:endParaRPr lang="en-US"/>
           </a:p>
@@ -1215,7 +1418,7 @@
           <a:p>
             <a:fld id="{0EF240FC-2CF2-4EB1-8271-F3765CBA0906}" type="slidenum">
               <a:rPr lang="en-US" smtClean="0"/>
-              <a:t>19</a:t>
+              <a:t>20</a:t>
             </a:fld>
             <a:endParaRPr lang="en-US"/>
           </a:p>
@@ -1299,7 +1502,7 @@
           <a:p>
             <a:fld id="{0EF240FC-2CF2-4EB1-8271-F3765CBA0906}" type="slidenum">
               <a:rPr lang="en-US" smtClean="0"/>
-              <a:t>20</a:t>
+              <a:t>21</a:t>
             </a:fld>
             <a:endParaRPr lang="en-US"/>
           </a:p>
@@ -2031,7 +2234,7 @@
           <a:p>
             <a:fld id="{0EF240FC-2CF2-4EB1-8271-F3765CBA0906}" type="slidenum">
               <a:rPr lang="en-US" smtClean="0"/>
-              <a:t>12</a:t>
+              <a:t>13</a:t>
             </a:fld>
             <a:endParaRPr lang="en-US"/>
           </a:p>
@@ -2244,7 +2447,7 @@
           <a:p>
             <a:fld id="{DE5CB39B-8E5F-485E-A282-592B276E07F9}" type="datetimeFigureOut">
               <a:rPr lang="en-US" smtClean="0"/>
-              <a:t>3/5/2026</a:t>
+              <a:t>3/17/2026</a:t>
             </a:fld>
             <a:endParaRPr lang="en-US"/>
           </a:p>
@@ -2420,7 +2623,7 @@
           <a:p>
             <a:fld id="{DE5CB39B-8E5F-485E-A282-592B276E07F9}" type="datetimeFigureOut">
               <a:rPr lang="en-US" smtClean="0"/>
-              <a:t>3/5/2026</a:t>
+              <a:t>3/17/2026</a:t>
             </a:fld>
             <a:endParaRPr lang="en-US"/>
           </a:p>
@@ -2598,7 +2801,7 @@
           <a:p>
             <a:fld id="{DE5CB39B-8E5F-485E-A282-592B276E07F9}" type="datetimeFigureOut">
               <a:rPr lang="en-US" smtClean="0"/>
-              <a:t>3/5/2026</a:t>
+              <a:t>3/17/2026</a:t>
             </a:fld>
             <a:endParaRPr lang="en-US"/>
           </a:p>
@@ -2768,7 +2971,7 @@
           <a:p>
             <a:fld id="{DE5CB39B-8E5F-485E-A282-592B276E07F9}" type="datetimeFigureOut">
               <a:rPr lang="en-US" smtClean="0"/>
-              <a:t>3/5/2026</a:t>
+              <a:t>3/17/2026</a:t>
             </a:fld>
             <a:endParaRPr lang="en-US"/>
           </a:p>
@@ -3014,7 +3217,7 @@
           <a:p>
             <a:fld id="{DE5CB39B-8E5F-485E-A282-592B276E07F9}" type="datetimeFigureOut">
               <a:rPr lang="en-US" smtClean="0"/>
-              <a:t>3/5/2026</a:t>
+              <a:t>3/17/2026</a:t>
             </a:fld>
             <a:endParaRPr lang="en-US"/>
           </a:p>
@@ -3300,7 +3503,7 @@
           <a:p>
             <a:fld id="{DE5CB39B-8E5F-485E-A282-592B276E07F9}" type="datetimeFigureOut">
               <a:rPr lang="en-US" smtClean="0"/>
-              <a:t>3/5/2026</a:t>
+              <a:t>3/17/2026</a:t>
             </a:fld>
             <a:endParaRPr lang="en-US"/>
           </a:p>
@@ -3720,7 +3923,7 @@
           <a:p>
             <a:fld id="{DE5CB39B-8E5F-485E-A282-592B276E07F9}" type="datetimeFigureOut">
               <a:rPr lang="en-US" smtClean="0"/>
-              <a:t>3/5/2026</a:t>
+              <a:t>3/17/2026</a:t>
             </a:fld>
             <a:endParaRPr lang="en-US"/>
           </a:p>
@@ -3842,7 +4045,7 @@
           <a:p>
             <a:fld id="{DE5CB39B-8E5F-485E-A282-592B276E07F9}" type="datetimeFigureOut">
               <a:rPr lang="en-US" smtClean="0"/>
-              <a:t>3/5/2026</a:t>
+              <a:t>3/17/2026</a:t>
             </a:fld>
             <a:endParaRPr lang="en-US"/>
           </a:p>
@@ -3937,7 +4140,7 @@
           <a:p>
             <a:fld id="{DE5CB39B-8E5F-485E-A282-592B276E07F9}" type="datetimeFigureOut">
               <a:rPr lang="en-US" smtClean="0"/>
-              <a:t>3/5/2026</a:t>
+              <a:t>3/17/2026</a:t>
             </a:fld>
             <a:endParaRPr lang="en-US"/>
           </a:p>
@@ -4214,7 +4417,7 @@
           <a:p>
             <a:fld id="{DE5CB39B-8E5F-485E-A282-592B276E07F9}" type="datetimeFigureOut">
               <a:rPr lang="en-US" smtClean="0"/>
-              <a:t>3/5/2026</a:t>
+              <a:t>3/17/2026</a:t>
             </a:fld>
             <a:endParaRPr lang="en-US"/>
           </a:p>
@@ -4469,7 +4672,7 @@
           <a:p>
             <a:fld id="{DE5CB39B-8E5F-485E-A282-592B276E07F9}" type="datetimeFigureOut">
               <a:rPr lang="en-US" smtClean="0"/>
-              <a:t>3/5/2026</a:t>
+              <a:t>3/17/2026</a:t>
             </a:fld>
             <a:endParaRPr lang="en-US"/>
           </a:p>
@@ -4940,7 +5143,7 @@
           <a:p>
             <a:fld id="{DE5CB39B-8E5F-485E-A282-592B276E07F9}" type="datetimeFigureOut">
               <a:rPr lang="en-US" smtClean="0"/>
-              <a:t>3/5/2026</a:t>
+              <a:t>3/17/2026</a:t>
             </a:fld>
             <a:endParaRPr lang="en-US"/>
           </a:p>
@@ -5497,11 +5700,17 @@
 </file>
 
 <file path=ppt/slides/slide10.xml><?xml version="1.0" encoding="utf-8"?>
-<p:sld xmlns:a="http://schemas.openxmlformats.org/drawingml/2006/main" xmlns:r="http://schemas.openxmlformats.org/officeDocument/2006/relationships" xmlns:p="http://schemas.openxmlformats.org/presentationml/2006/main">
+<p:sld xmlns:a="http://schemas.openxmlformats.org/drawingml/2006/main" xmlns:r="http://schemas.openxmlformats.org/officeDocument/2006/relationships" xmlns:p="http://schemas.openxmlformats.org/presentationml/2006/main" show="0">
   <p:cSld>
     <p:spTree>
       <p:nvGrpSpPr>
-        <p:cNvPr id="1" name=""/>
+        <p:cNvPr id="1" name="">
+          <a:extLst>
+            <a:ext uri="{FF2B5EF4-FFF2-40B4-BE49-F238E27FC236}">
+              <a16:creationId xmlns:a16="http://schemas.microsoft.com/office/drawing/2014/main" id="{740F1271-D728-A036-086C-DE20B043E5E2}"/>
+            </a:ext>
+          </a:extLst>
+        </p:cNvPr>
         <p:cNvGrpSpPr/>
         <p:nvPr/>
       </p:nvGrpSpPr>
@@ -5515,55 +5724,38 @@
       </p:grpSpPr>
       <p:pic>
         <p:nvPicPr>
-          <p:cNvPr id="3" name="Picture 2">
+          <p:cNvPr id="7" name="Picture 6">
             <a:extLst>
               <a:ext uri="{FF2B5EF4-FFF2-40B4-BE49-F238E27FC236}">
-                <a16:creationId xmlns:a16="http://schemas.microsoft.com/office/drawing/2014/main" id="{5F9BED00-9EE8-97B3-F1A0-63518422A6DB}"/>
+                <a16:creationId xmlns:a16="http://schemas.microsoft.com/office/drawing/2014/main" id="{239C21E0-2056-BDD4-1BBD-CCD72364D862}"/>
               </a:ext>
             </a:extLst>
           </p:cNvPr>
           <p:cNvPicPr>
-            <a:picLocks noChangeAspect="1" noChangeArrowheads="1"/>
+            <a:picLocks noChangeAspect="1"/>
           </p:cNvPicPr>
           <p:nvPr/>
         </p:nvPicPr>
         <p:blipFill>
-          <a:blip r:embed="rId2">
-            <a:extLst>
-              <a:ext uri="{28A0092B-C50C-407E-A947-70E740481C1C}">
-                <a14:useLocalDpi xmlns:a14="http://schemas.microsoft.com/office/drawing/2010/main" val="0"/>
-              </a:ext>
-            </a:extLst>
-          </a:blip>
-          <a:srcRect/>
+          <a:blip r:embed="rId2"/>
           <a:stretch>
             <a:fillRect/>
           </a:stretch>
         </p:blipFill>
-        <p:spPr bwMode="auto">
+        <p:spPr>
           <a:xfrm>
-            <a:off x="1466850" y="608428"/>
-            <a:ext cx="6210300" cy="6080760"/>
+            <a:off x="1545037" y="1836603"/>
+            <a:ext cx="6053925" cy="3184793"/>
           </a:xfrm>
           <a:prstGeom prst="rect">
             <a:avLst/>
           </a:prstGeom>
-          <a:noFill/>
-          <a:extLst>
-            <a:ext uri="{909E8E84-426E-40DD-AFC4-6F175D3DCCD1}">
-              <a14:hiddenFill xmlns:a14="http://schemas.microsoft.com/office/drawing/2010/main">
-                <a:solidFill>
-                  <a:srgbClr val="FFFFFF"/>
-                </a:solidFill>
-              </a14:hiddenFill>
-            </a:ext>
-          </a:extLst>
         </p:spPr>
       </p:pic>
     </p:spTree>
     <p:extLst>
       <p:ext uri="{BB962C8B-B14F-4D97-AF65-F5344CB8AC3E}">
-        <p14:creationId xmlns:p14="http://schemas.microsoft.com/office/powerpoint/2010/main" val="2531377879"/>
+        <p14:creationId xmlns:p14="http://schemas.microsoft.com/office/powerpoint/2010/main" val="1223413549"/>
       </p:ext>
     </p:extLst>
   </p:cSld>
@@ -5590,85 +5782,94 @@
           <a:chExt cx="0" cy="0"/>
         </a:xfrm>
       </p:grpSpPr>
-      <p:sp>
-        <p:nvSpPr>
-          <p:cNvPr id="3" name="Rectangle 2"/>
-          <p:cNvSpPr/>
+      <p:pic>
+        <p:nvPicPr>
+          <p:cNvPr id="4" name="Picture 3">
+            <a:extLst>
+              <a:ext uri="{FF2B5EF4-FFF2-40B4-BE49-F238E27FC236}">
+                <a16:creationId xmlns:a16="http://schemas.microsoft.com/office/drawing/2014/main" id="{366EDCC8-CDF2-FB69-347E-2381520ADB79}"/>
+              </a:ext>
+            </a:extLst>
+          </p:cNvPr>
+          <p:cNvPicPr>
+            <a:picLocks noChangeAspect="1"/>
+          </p:cNvPicPr>
           <p:nvPr/>
-        </p:nvSpPr>
+        </p:nvPicPr>
+        <p:blipFill>
+          <a:blip r:embed="rId2"/>
+          <a:stretch>
+            <a:fillRect/>
+          </a:stretch>
+        </p:blipFill>
         <p:spPr>
           <a:xfrm>
-            <a:off x="1635823" y="6450568"/>
-            <a:ext cx="5943600" cy="369332"/>
+            <a:off x="1092200" y="684721"/>
+            <a:ext cx="6959600" cy="6057900"/>
           </a:xfrm>
           <a:prstGeom prst="rect">
             <a:avLst/>
           </a:prstGeom>
         </p:spPr>
-        <p:txBody>
-          <a:bodyPr wrap="square">
-            <a:spAutoFit/>
-          </a:bodyPr>
-          <a:lstStyle/>
-          <a:p>
-            <a:r>
-              <a:rPr lang="en-US" b="1" dirty="0">
-                <a:latin typeface="Arial" panose="020B0604020202020204" pitchFamily="34" charset="0"/>
-              </a:rPr>
-              <a:t>*** NOTE:  All times listed are Eastern Time (US) ***</a:t>
-            </a:r>
-            <a:r>
-              <a:rPr lang="en-US" dirty="0"/>
-              <a:t> </a:t>
-            </a:r>
-          </a:p>
-        </p:txBody>
-      </p:sp>
+      </p:pic>
+    </p:spTree>
+    <p:extLst>
+      <p:ext uri="{BB962C8B-B14F-4D97-AF65-F5344CB8AC3E}">
+        <p14:creationId xmlns:p14="http://schemas.microsoft.com/office/powerpoint/2010/main" val="2531377879"/>
+      </p:ext>
+    </p:extLst>
+  </p:cSld>
+  <p:clrMapOvr>
+    <a:masterClrMapping/>
+  </p:clrMapOvr>
+</p:sld>
+</file>
+
+<file path=ppt/slides/slide12.xml><?xml version="1.0" encoding="utf-8"?>
+<p:sld xmlns:a="http://schemas.openxmlformats.org/drawingml/2006/main" xmlns:r="http://schemas.openxmlformats.org/officeDocument/2006/relationships" xmlns:p="http://schemas.openxmlformats.org/presentationml/2006/main">
+  <p:cSld>
+    <p:spTree>
+      <p:nvGrpSpPr>
+        <p:cNvPr id="1" name=""/>
+        <p:cNvGrpSpPr/>
+        <p:nvPr/>
+      </p:nvGrpSpPr>
+      <p:grpSpPr>
+        <a:xfrm>
+          <a:off x="0" y="0"/>
+          <a:ext cx="0" cy="0"/>
+          <a:chOff x="0" y="0"/>
+          <a:chExt cx="0" cy="0"/>
+        </a:xfrm>
+      </p:grpSpPr>
       <p:pic>
         <p:nvPicPr>
-          <p:cNvPr id="2" name="Picture 1">
+          <p:cNvPr id="6" name="Picture 5">
             <a:extLst>
               <a:ext uri="{FF2B5EF4-FFF2-40B4-BE49-F238E27FC236}">
-                <a16:creationId xmlns:a16="http://schemas.microsoft.com/office/drawing/2014/main" id="{7CAC2639-A430-756D-9695-B1D8994D6E72}"/>
+                <a16:creationId xmlns:a16="http://schemas.microsoft.com/office/drawing/2014/main" id="{40A90E59-D996-3D4D-D33C-3C680C687C59}"/>
               </a:ext>
             </a:extLst>
           </p:cNvPr>
           <p:cNvPicPr>
-            <a:picLocks noChangeAspect="1" noChangeArrowheads="1"/>
+            <a:picLocks noChangeAspect="1"/>
           </p:cNvPicPr>
           <p:nvPr/>
         </p:nvPicPr>
         <p:blipFill>
-          <a:blip r:embed="rId2">
-            <a:extLst>
-              <a:ext uri="{28A0092B-C50C-407E-A947-70E740481C1C}">
-                <a14:useLocalDpi xmlns:a14="http://schemas.microsoft.com/office/drawing/2010/main" val="0"/>
-              </a:ext>
-            </a:extLst>
-          </a:blip>
-          <a:srcRect/>
+          <a:blip r:embed="rId2"/>
           <a:stretch>
             <a:fillRect/>
           </a:stretch>
         </p:blipFill>
-        <p:spPr bwMode="auto">
+        <p:spPr>
           <a:xfrm>
-            <a:off x="1502473" y="1383030"/>
-            <a:ext cx="6210300" cy="4091940"/>
+            <a:off x="1092200" y="1206500"/>
+            <a:ext cx="6959600" cy="4445000"/>
           </a:xfrm>
           <a:prstGeom prst="rect">
             <a:avLst/>
           </a:prstGeom>
-          <a:noFill/>
-          <a:extLst>
-            <a:ext uri="{909E8E84-426E-40DD-AFC4-6F175D3DCCD1}">
-              <a14:hiddenFill xmlns:a14="http://schemas.microsoft.com/office/drawing/2010/main">
-                <a:solidFill>
-                  <a:srgbClr val="FFFFFF"/>
-                </a:solidFill>
-              </a14:hiddenFill>
-            </a:ext>
-          </a:extLst>
         </p:spPr>
       </p:pic>
     </p:spTree>
@@ -5684,7 +5885,7 @@
 </p:sld>
 </file>
 
-<file path=ppt/slides/slide12.xml><?xml version="1.0" encoding="utf-8"?>
+<file path=ppt/slides/slide13.xml><?xml version="1.0" encoding="utf-8"?>
 <p:sld xmlns:a="http://schemas.openxmlformats.org/drawingml/2006/main" xmlns:r="http://schemas.openxmlformats.org/officeDocument/2006/relationships" xmlns:p="http://schemas.openxmlformats.org/presentationml/2006/main" show="0">
   <p:cSld>
     <p:spTree>
@@ -5776,97 +5977,6 @@
     <p:extLst>
       <p:ext uri="{BB962C8B-B14F-4D97-AF65-F5344CB8AC3E}">
         <p14:creationId xmlns:p14="http://schemas.microsoft.com/office/powerpoint/2010/main" val="2866807430"/>
-      </p:ext>
-    </p:extLst>
-  </p:cSld>
-  <p:clrMapOvr>
-    <a:masterClrMapping/>
-  </p:clrMapOvr>
-</p:sld>
-</file>
-
-<file path=ppt/slides/slide13.xml><?xml version="1.0" encoding="utf-8"?>
-<p:sld xmlns:a="http://schemas.openxmlformats.org/drawingml/2006/main" xmlns:r="http://schemas.openxmlformats.org/officeDocument/2006/relationships" xmlns:p="http://schemas.openxmlformats.org/presentationml/2006/main">
-  <p:cSld>
-    <p:spTree>
-      <p:nvGrpSpPr>
-        <p:cNvPr id="1" name=""/>
-        <p:cNvGrpSpPr/>
-        <p:nvPr/>
-      </p:nvGrpSpPr>
-      <p:grpSpPr>
-        <a:xfrm>
-          <a:off x="0" y="0"/>
-          <a:ext cx="0" cy="0"/>
-          <a:chOff x="0" y="0"/>
-          <a:chExt cx="0" cy="0"/>
-        </a:xfrm>
-      </p:grpSpPr>
-      <p:sp>
-        <p:nvSpPr>
-          <p:cNvPr id="2" name="Title 1"/>
-          <p:cNvSpPr>
-            <a:spLocks noGrp="1"/>
-          </p:cNvSpPr>
-          <p:nvPr>
-            <p:ph type="title"/>
-          </p:nvPr>
-        </p:nvSpPr>
-        <p:spPr/>
-        <p:txBody>
-          <a:bodyPr/>
-          <a:lstStyle/>
-          <a:p>
-            <a:r>
-              <a:rPr lang="en-US" dirty="0"/>
-              <a:t>Academic Freedom</a:t>
-            </a:r>
-          </a:p>
-        </p:txBody>
-      </p:sp>
-      <p:sp>
-        <p:nvSpPr>
-          <p:cNvPr id="3" name="Content Placeholder 2"/>
-          <p:cNvSpPr>
-            <a:spLocks noGrp="1"/>
-          </p:cNvSpPr>
-          <p:nvPr>
-            <p:ph idx="1"/>
-          </p:nvPr>
-        </p:nvSpPr>
-        <p:spPr/>
-        <p:txBody>
-          <a:bodyPr>
-            <a:normAutofit/>
-          </a:bodyPr>
-          <a:lstStyle/>
-          <a:p>
-            <a:r>
-              <a:rPr lang="en-US" sz="2400" dirty="0"/>
-              <a:t>You may express your opinions concerning current or proposed policies, regulations and procedures openly, honestly, and professionally</a:t>
-            </a:r>
-          </a:p>
-          <a:p>
-            <a:r>
-              <a:rPr lang="en-US" sz="2400" dirty="0"/>
-              <a:t>You may not attack the character, personality or other personal attributes of any individual</a:t>
-            </a:r>
-          </a:p>
-          <a:p>
-            <a:r>
-              <a:rPr lang="en-US" sz="2400" dirty="0"/>
-              <a:t>Academic freedom must be tempered by good judgment to refrain from making offensive remarks, unfounded opinions, or irresponsible statements.</a:t>
-            </a:r>
-          </a:p>
-          <a:p>
-            <a:endParaRPr lang="en-US" sz="2400" dirty="0"/>
-          </a:p>
-        </p:txBody>
-      </p:sp>
-    </p:spTree>
-    <p:extLst>
-      <p:ext uri="{BB962C8B-B14F-4D97-AF65-F5344CB8AC3E}">
-        <p14:creationId xmlns:p14="http://schemas.microsoft.com/office/powerpoint/2010/main" val="4162582292"/>
       </p:ext>
     </p:extLst>
   </p:cSld>
@@ -5910,7 +6020,7 @@
           <a:p>
             <a:r>
               <a:rPr lang="en-US" dirty="0"/>
-              <a:t>Non-attribution</a:t>
+              <a:t>Academic Freedom</a:t>
             </a:r>
           </a:p>
         </p:txBody>
@@ -5928,19 +6038,25 @@
         <p:spPr/>
         <p:txBody>
           <a:bodyPr>
-            <a:noAutofit/>
+            <a:normAutofit/>
           </a:bodyPr>
           <a:lstStyle/>
           <a:p>
             <a:r>
               <a:rPr lang="en-US" sz="2400" dirty="0"/>
-              <a:t>What you say in class will not be attributed to you if and when your thoughts or ideas are repeated outside of class</a:t>
+              <a:t>You may express your opinions concerning current or proposed policies, regulations and procedures openly, honestly, and professionally</a:t>
             </a:r>
           </a:p>
           <a:p>
             <a:r>
               <a:rPr lang="en-US" sz="2400" dirty="0"/>
-              <a:t>All guest speakers, students, and permanent-party personnel are prohibited from divulging the identity of any particular speaker, whether a guest speaker, faculty member, or student, for the purpose of attributing to that speaker any specific remarks or statements, including but not limited to offensive remarks and irresponsible statements.</a:t>
+              <a:t>You may not attack the character, personality or other personal attributes of any individual</a:t>
+            </a:r>
+          </a:p>
+          <a:p>
+            <a:r>
+              <a:rPr lang="en-US" sz="2400" dirty="0"/>
+              <a:t>Academic freedom must be tempered by good judgment to refrain from making offensive remarks, unfounded opinions, or irresponsible statements.</a:t>
             </a:r>
           </a:p>
           <a:p>
@@ -5951,7 +6067,7 @@
     </p:spTree>
     <p:extLst>
       <p:ext uri="{BB962C8B-B14F-4D97-AF65-F5344CB8AC3E}">
-        <p14:creationId xmlns:p14="http://schemas.microsoft.com/office/powerpoint/2010/main" val="2163131506"/>
+        <p14:creationId xmlns:p14="http://schemas.microsoft.com/office/powerpoint/2010/main" val="4162582292"/>
       </p:ext>
     </p:extLst>
   </p:cSld>
@@ -5995,7 +6111,7 @@
           <a:p>
             <a:r>
               <a:rPr lang="en-US" dirty="0"/>
-              <a:t>Academic Integrity</a:t>
+              <a:t>Non-attribution</a:t>
             </a:r>
           </a:p>
         </p:txBody>
@@ -6013,21 +6129,30 @@
         <p:spPr/>
         <p:txBody>
           <a:bodyPr>
-            <a:normAutofit/>
+            <a:noAutofit/>
           </a:bodyPr>
           <a:lstStyle/>
           <a:p>
             <a:r>
               <a:rPr lang="en-US" sz="2400" dirty="0"/>
-              <a:t>No tests, assignments, or grades in this class</a:t>
-            </a:r>
+              <a:t>What you say in class will not be attributed to you if and when your thoughts or ideas are repeated outside of class</a:t>
+            </a:r>
+          </a:p>
+          <a:p>
+            <a:r>
+              <a:rPr lang="en-US" sz="2400" dirty="0"/>
+              <a:t>All guest speakers, students, and permanent-party personnel are prohibited from divulging the identity of any particular speaker, whether a guest speaker, faculty member, or student, for the purpose of attributing to that speaker any specific remarks or statements, including but not limited to offensive remarks and irresponsible statements.</a:t>
+            </a:r>
+          </a:p>
+          <a:p>
+            <a:endParaRPr lang="en-US" sz="2400" dirty="0"/>
           </a:p>
         </p:txBody>
       </p:sp>
     </p:spTree>
     <p:extLst>
       <p:ext uri="{BB962C8B-B14F-4D97-AF65-F5344CB8AC3E}">
-        <p14:creationId xmlns:p14="http://schemas.microsoft.com/office/powerpoint/2010/main" val="242003072"/>
+        <p14:creationId xmlns:p14="http://schemas.microsoft.com/office/powerpoint/2010/main" val="2163131506"/>
       </p:ext>
     </p:extLst>
   </p:cSld>
@@ -6038,7 +6163,7 @@
 </file>
 
 <file path=ppt/slides/slide16.xml><?xml version="1.0" encoding="utf-8"?>
-<p:sld xmlns:a="http://schemas.openxmlformats.org/drawingml/2006/main" xmlns:r="http://schemas.openxmlformats.org/officeDocument/2006/relationships" xmlns:p="http://schemas.openxmlformats.org/presentationml/2006/main" show="0">
+<p:sld xmlns:a="http://schemas.openxmlformats.org/drawingml/2006/main" xmlns:r="http://schemas.openxmlformats.org/officeDocument/2006/relationships" xmlns:p="http://schemas.openxmlformats.org/presentationml/2006/main">
   <p:cSld>
     <p:spTree>
       <p:nvGrpSpPr>
@@ -6071,7 +6196,7 @@
           <a:p>
             <a:r>
               <a:rPr lang="en-US" dirty="0"/>
-              <a:t>Cell Phones/Email</a:t>
+              <a:t>Academic Integrity</a:t>
             </a:r>
           </a:p>
         </p:txBody>
@@ -6095,13 +6220,7 @@
           <a:p>
             <a:r>
               <a:rPr lang="en-US" sz="2400" dirty="0"/>
-              <a:t>You know the drill</a:t>
-            </a:r>
-          </a:p>
-          <a:p>
-            <a:r>
-              <a:rPr lang="en-US" sz="2400" dirty="0"/>
-              <a:t>Step out if you need to take a call</a:t>
+              <a:t>No tests, assignments, or grades in this class</a:t>
             </a:r>
           </a:p>
         </p:txBody>
@@ -6109,7 +6228,7 @@
     </p:spTree>
     <p:extLst>
       <p:ext uri="{BB962C8B-B14F-4D97-AF65-F5344CB8AC3E}">
-        <p14:creationId xmlns:p14="http://schemas.microsoft.com/office/powerpoint/2010/main" val="2992313897"/>
+        <p14:creationId xmlns:p14="http://schemas.microsoft.com/office/powerpoint/2010/main" val="242003072"/>
       </p:ext>
     </p:extLst>
   </p:cSld>
@@ -6153,7 +6272,7 @@
           <a:p>
             <a:r>
               <a:rPr lang="en-US" dirty="0"/>
-              <a:t>Facilities</a:t>
+              <a:t>Cell Phones/Email</a:t>
             </a:r>
           </a:p>
         </p:txBody>
@@ -6177,19 +6296,13 @@
           <a:p>
             <a:r>
               <a:rPr lang="en-US" sz="2400" dirty="0"/>
-              <a:t>Break Room / Vending</a:t>
+              <a:t>You know the drill</a:t>
             </a:r>
           </a:p>
           <a:p>
             <a:r>
               <a:rPr lang="en-US" sz="2400" dirty="0"/>
-              <a:t>Rest Rooms</a:t>
-            </a:r>
-          </a:p>
-          <a:p>
-            <a:r>
-              <a:rPr lang="en-US" sz="2400" dirty="0"/>
-              <a:t>In case of emergency</a:t>
+              <a:t>Step out if you need to take a call</a:t>
             </a:r>
           </a:p>
         </p:txBody>
@@ -6197,7 +6310,7 @@
     </p:spTree>
     <p:extLst>
       <p:ext uri="{BB962C8B-B14F-4D97-AF65-F5344CB8AC3E}">
-        <p14:creationId xmlns:p14="http://schemas.microsoft.com/office/powerpoint/2010/main" val="766170544"/>
+        <p14:creationId xmlns:p14="http://schemas.microsoft.com/office/powerpoint/2010/main" val="2992313897"/>
       </p:ext>
     </p:extLst>
   </p:cSld>
@@ -6208,7 +6321,7 @@
 </file>
 
 <file path=ppt/slides/slide18.xml><?xml version="1.0" encoding="utf-8"?>
-<p:sld xmlns:a="http://schemas.openxmlformats.org/drawingml/2006/main" xmlns:r="http://schemas.openxmlformats.org/officeDocument/2006/relationships" xmlns:p="http://schemas.openxmlformats.org/presentationml/2006/main">
+<p:sld xmlns:a="http://schemas.openxmlformats.org/drawingml/2006/main" xmlns:r="http://schemas.openxmlformats.org/officeDocument/2006/relationships" xmlns:p="http://schemas.openxmlformats.org/presentationml/2006/main" show="0">
   <p:cSld>
     <p:spTree>
       <p:nvGrpSpPr>
@@ -6241,7 +6354,7 @@
           <a:p>
             <a:r>
               <a:rPr lang="en-US" dirty="0"/>
-              <a:t>Live Course via Classroom</a:t>
+              <a:t>Facilities</a:t>
             </a:r>
           </a:p>
         </p:txBody>
@@ -6256,12 +6369,7 @@
             <p:ph idx="1"/>
           </p:nvPr>
         </p:nvSpPr>
-        <p:spPr>
-          <a:xfrm>
-            <a:off x="579120" y="1615440"/>
-            <a:ext cx="8229600" cy="5448300"/>
-          </a:xfrm>
-        </p:spPr>
+        <p:spPr/>
         <p:txBody>
           <a:bodyPr>
             <a:normAutofit/>
@@ -6270,84 +6378,27 @@
           <a:p>
             <a:r>
               <a:rPr lang="en-US" sz="2400" dirty="0"/>
-              <a:t>Access to a Python-enabled IDE</a:t>
-            </a:r>
-          </a:p>
-          <a:p>
-            <a:pPr lvl="1"/>
-            <a:r>
-              <a:rPr lang="en-US" sz="2000" dirty="0"/>
-              <a:t>Recommended Anaconda Cloud</a:t>
-            </a:r>
-          </a:p>
-          <a:p>
-            <a:pPr marL="457200" lvl="1" indent="0">
-              <a:buNone/>
-            </a:pPr>
-            <a:endParaRPr lang="en-US" sz="2000" dirty="0"/>
+              <a:t>Break Room / Vending</a:t>
+            </a:r>
           </a:p>
           <a:p>
             <a:r>
               <a:rPr lang="en-US" sz="2400" dirty="0"/>
-              <a:t>Recommended Setup – 2 screens</a:t>
-            </a:r>
-          </a:p>
-          <a:p>
-            <a:pPr lvl="1"/>
-            <a:r>
-              <a:rPr lang="en-US" sz="2000" dirty="0"/>
-              <a:t>One dedicated to video and presentations</a:t>
-            </a:r>
-          </a:p>
-          <a:p>
-            <a:pPr lvl="1"/>
-            <a:r>
-              <a:rPr lang="en-US" sz="2000" dirty="0"/>
-              <a:t>Second for independent work on course files</a:t>
-            </a:r>
-          </a:p>
-          <a:p>
-            <a:pPr lvl="1"/>
-            <a:endParaRPr lang="en-US" sz="2000" dirty="0"/>
+              <a:t>Rest Rooms</a:t>
+            </a:r>
           </a:p>
           <a:p>
             <a:r>
               <a:rPr lang="en-US" sz="2400" dirty="0"/>
-              <a:t>For Python file/data manipulation – computer mouse vice laptop touch pads or touch screens</a:t>
-            </a:r>
-          </a:p>
-          <a:p>
-            <a:pPr marL="0" indent="0">
-              <a:buNone/>
-            </a:pPr>
-            <a:endParaRPr lang="en-US" sz="2400" dirty="0"/>
-          </a:p>
-          <a:p>
-            <a:r>
-              <a:rPr lang="en-US" sz="2400" dirty="0"/>
-              <a:t>Internet Connectivity</a:t>
-            </a:r>
-          </a:p>
-          <a:p>
-            <a:pPr lvl="1"/>
-            <a:r>
-              <a:rPr lang="en-US" sz="2000" dirty="0"/>
-              <a:t>VPN required to access </a:t>
-            </a:r>
-            <a:r>
-              <a:rPr lang="en-US" sz="1400" dirty="0">
-                <a:hlinkClick r:id="rId3"/>
-              </a:rPr>
-              <a:t>STITCHES</a:t>
-            </a:r>
-            <a:endParaRPr lang="en-US" sz="2000" dirty="0"/>
+              <a:t>In case of emergency</a:t>
+            </a:r>
           </a:p>
         </p:txBody>
       </p:sp>
     </p:spTree>
     <p:extLst>
       <p:ext uri="{BB962C8B-B14F-4D97-AF65-F5344CB8AC3E}">
-        <p14:creationId xmlns:p14="http://schemas.microsoft.com/office/powerpoint/2010/main" val="674039978"/>
+        <p14:creationId xmlns:p14="http://schemas.microsoft.com/office/powerpoint/2010/main" val="766170544"/>
       </p:ext>
     </p:extLst>
   </p:cSld>
@@ -6391,7 +6442,7 @@
           <a:p>
             <a:r>
               <a:rPr lang="en-US" dirty="0"/>
-              <a:t>Introductions and Expectations</a:t>
+              <a:t>Live Course via Classroom</a:t>
             </a:r>
           </a:p>
         </p:txBody>
@@ -6406,7 +6457,12 @@
             <p:ph idx="1"/>
           </p:nvPr>
         </p:nvSpPr>
-        <p:spPr/>
+        <p:spPr>
+          <a:xfrm>
+            <a:off x="579120" y="1615440"/>
+            <a:ext cx="8229600" cy="5448300"/>
+          </a:xfrm>
+        </p:spPr>
         <p:txBody>
           <a:bodyPr>
             <a:normAutofit/>
@@ -6415,27 +6471,84 @@
           <a:p>
             <a:r>
               <a:rPr lang="en-US" sz="2400" dirty="0"/>
-              <a:t>Name</a:t>
-            </a:r>
+              <a:t>Access to a Python-enabled IDE</a:t>
+            </a:r>
+          </a:p>
+          <a:p>
+            <a:pPr lvl="1"/>
+            <a:r>
+              <a:rPr lang="en-US" sz="2000" dirty="0"/>
+              <a:t>Recommended Stitches or Anaconda Cloud</a:t>
+            </a:r>
+          </a:p>
+          <a:p>
+            <a:pPr marL="457200" lvl="1" indent="0">
+              <a:buNone/>
+            </a:pPr>
+            <a:endParaRPr lang="en-US" sz="2000" dirty="0"/>
           </a:p>
           <a:p>
             <a:r>
               <a:rPr lang="en-US" sz="2400" dirty="0"/>
-              <a:t>Current Position</a:t>
-            </a:r>
+              <a:t>Recommended Setup – 2 screens</a:t>
+            </a:r>
+          </a:p>
+          <a:p>
+            <a:pPr lvl="1"/>
+            <a:r>
+              <a:rPr lang="en-US" sz="2000" dirty="0"/>
+              <a:t>One dedicated to video and presentations</a:t>
+            </a:r>
+          </a:p>
+          <a:p>
+            <a:pPr lvl="1"/>
+            <a:r>
+              <a:rPr lang="en-US" sz="2000" dirty="0"/>
+              <a:t>Second for independent work on course files</a:t>
+            </a:r>
+          </a:p>
+          <a:p>
+            <a:pPr lvl="1"/>
+            <a:endParaRPr lang="en-US" sz="2000" dirty="0"/>
           </a:p>
           <a:p>
             <a:r>
               <a:rPr lang="en-US" sz="2400" dirty="0"/>
-              <a:t>What do you hope to get out of this course?</a:t>
-            </a:r>
+              <a:t>For Python file/data manipulation – computer mouse vice laptop touch pads or touch screens</a:t>
+            </a:r>
+          </a:p>
+          <a:p>
+            <a:pPr marL="0" indent="0">
+              <a:buNone/>
+            </a:pPr>
+            <a:endParaRPr lang="en-US" sz="2400" dirty="0"/>
+          </a:p>
+          <a:p>
+            <a:r>
+              <a:rPr lang="en-US" sz="2400" dirty="0"/>
+              <a:t>Internet Connectivity</a:t>
+            </a:r>
+          </a:p>
+          <a:p>
+            <a:pPr lvl="1"/>
+            <a:r>
+              <a:rPr lang="en-US" sz="2000" dirty="0"/>
+              <a:t>NIPR or VPN required to access </a:t>
+            </a:r>
+            <a:r>
+              <a:rPr lang="en-US" sz="1400" dirty="0">
+                <a:hlinkClick r:id="rId3"/>
+              </a:rPr>
+              <a:t>STITCHES</a:t>
+            </a:r>
+            <a:endParaRPr lang="en-US" sz="2000" dirty="0"/>
           </a:p>
         </p:txBody>
       </p:sp>
     </p:spTree>
     <p:extLst>
       <p:ext uri="{BB962C8B-B14F-4D97-AF65-F5344CB8AC3E}">
-        <p14:creationId xmlns:p14="http://schemas.microsoft.com/office/powerpoint/2010/main" val="657998128"/>
+        <p14:creationId xmlns:p14="http://schemas.microsoft.com/office/powerpoint/2010/main" val="674039978"/>
       </p:ext>
     </p:extLst>
   </p:cSld>
@@ -6738,6 +6851,94 @@
       </p:grpSpPr>
       <p:sp>
         <p:nvSpPr>
+          <p:cNvPr id="2" name="Title 1"/>
+          <p:cNvSpPr>
+            <a:spLocks noGrp="1"/>
+          </p:cNvSpPr>
+          <p:nvPr>
+            <p:ph type="title"/>
+          </p:nvPr>
+        </p:nvSpPr>
+        <p:spPr/>
+        <p:txBody>
+          <a:bodyPr/>
+          <a:lstStyle/>
+          <a:p>
+            <a:r>
+              <a:rPr lang="en-US" dirty="0"/>
+              <a:t>Introductions and Expectations</a:t>
+            </a:r>
+          </a:p>
+        </p:txBody>
+      </p:sp>
+      <p:sp>
+        <p:nvSpPr>
+          <p:cNvPr id="3" name="Content Placeholder 2"/>
+          <p:cNvSpPr>
+            <a:spLocks noGrp="1"/>
+          </p:cNvSpPr>
+          <p:nvPr>
+            <p:ph idx="1"/>
+          </p:nvPr>
+        </p:nvSpPr>
+        <p:spPr/>
+        <p:txBody>
+          <a:bodyPr>
+            <a:normAutofit/>
+          </a:bodyPr>
+          <a:lstStyle/>
+          <a:p>
+            <a:r>
+              <a:rPr lang="en-US" sz="2400" dirty="0"/>
+              <a:t>Name</a:t>
+            </a:r>
+          </a:p>
+          <a:p>
+            <a:r>
+              <a:rPr lang="en-US" sz="2400" dirty="0"/>
+              <a:t>Current Position</a:t>
+            </a:r>
+          </a:p>
+          <a:p>
+            <a:r>
+              <a:rPr lang="en-US" sz="2400" dirty="0"/>
+              <a:t>What do you hope to get out of this course?</a:t>
+            </a:r>
+          </a:p>
+        </p:txBody>
+      </p:sp>
+    </p:spTree>
+    <p:extLst>
+      <p:ext uri="{BB962C8B-B14F-4D97-AF65-F5344CB8AC3E}">
+        <p14:creationId xmlns:p14="http://schemas.microsoft.com/office/powerpoint/2010/main" val="657998128"/>
+      </p:ext>
+    </p:extLst>
+  </p:cSld>
+  <p:clrMapOvr>
+    <a:masterClrMapping/>
+  </p:clrMapOvr>
+</p:sld>
+</file>
+
+<file path=ppt/slides/slide21.xml><?xml version="1.0" encoding="utf-8"?>
+<p:sld xmlns:a="http://schemas.openxmlformats.org/drawingml/2006/main" xmlns:r="http://schemas.openxmlformats.org/officeDocument/2006/relationships" xmlns:p="http://schemas.openxmlformats.org/presentationml/2006/main">
+  <p:cSld>
+    <p:spTree>
+      <p:nvGrpSpPr>
+        <p:cNvPr id="1" name=""/>
+        <p:cNvGrpSpPr/>
+        <p:nvPr/>
+      </p:nvGrpSpPr>
+      <p:grpSpPr>
+        <a:xfrm>
+          <a:off x="0" y="0"/>
+          <a:ext cx="0" cy="0"/>
+          <a:chOff x="0" y="0"/>
+          <a:chExt cx="0" cy="0"/>
+        </a:xfrm>
+      </p:grpSpPr>
+      <p:sp>
+        <p:nvSpPr>
           <p:cNvPr id="4" name="Title 3"/>
           <p:cNvSpPr>
             <a:spLocks noGrp="1"/>
@@ -7503,7 +7704,7 @@
                 <a:ea typeface="Verdana"/>
                 <a:hlinkClick r:id="rId3"/>
               </a:rPr>
-              <a:t>Christopher.Swartz.6@us.af.mil</a:t>
+              <a:t>Christopher.Swartz.5.ctr@us.af.mil</a:t>
             </a:r>
             <a:r>
               <a:rPr lang="en-US" sz="2000" dirty="0">
@@ -7803,49 +8004,32 @@
       </p:grpSpPr>
       <p:pic>
         <p:nvPicPr>
-          <p:cNvPr id="2" name="Picture 1">
+          <p:cNvPr id="5" name="Picture 4">
             <a:extLst>
               <a:ext uri="{FF2B5EF4-FFF2-40B4-BE49-F238E27FC236}">
-                <a16:creationId xmlns:a16="http://schemas.microsoft.com/office/drawing/2014/main" id="{D6FC8C0B-8B96-89E3-9A15-141AA5726EC7}"/>
+                <a16:creationId xmlns:a16="http://schemas.microsoft.com/office/drawing/2014/main" id="{C189F0C7-740B-2DAF-BA9A-C62F38A44D75}"/>
               </a:ext>
             </a:extLst>
           </p:cNvPr>
           <p:cNvPicPr>
-            <a:picLocks noChangeAspect="1" noChangeArrowheads="1"/>
+            <a:picLocks noChangeAspect="1"/>
           </p:cNvPicPr>
           <p:nvPr/>
         </p:nvPicPr>
         <p:blipFill>
-          <a:blip r:embed="rId2">
-            <a:extLst>
-              <a:ext uri="{28A0092B-C50C-407E-A947-70E740481C1C}">
-                <a14:useLocalDpi xmlns:a14="http://schemas.microsoft.com/office/drawing/2010/main" val="0"/>
-              </a:ext>
-            </a:extLst>
-          </a:blip>
-          <a:srcRect/>
+          <a:blip r:embed="rId2"/>
           <a:stretch>
             <a:fillRect/>
           </a:stretch>
         </p:blipFill>
-        <p:spPr bwMode="auto">
+        <p:spPr>
           <a:xfrm>
-            <a:off x="1822246" y="714376"/>
-            <a:ext cx="5499508" cy="5924549"/>
+            <a:off x="1545037" y="707366"/>
+            <a:ext cx="6053926" cy="6014468"/>
           </a:xfrm>
           <a:prstGeom prst="rect">
             <a:avLst/>
           </a:prstGeom>
-          <a:noFill/>
-          <a:extLst>
-            <a:ext uri="{909E8E84-426E-40DD-AFC4-6F175D3DCCD1}">
-              <a14:hiddenFill xmlns:a14="http://schemas.microsoft.com/office/drawing/2010/main">
-                <a:solidFill>
-                  <a:srgbClr val="FFFFFF"/>
-                </a:solidFill>
-              </a14:hiddenFill>
-            </a:ext>
-          </a:extLst>
         </p:spPr>
       </p:pic>
     </p:spTree>
@@ -8773,6 +8957,17 @@
 </file>
 
 <file path=customXml/item2.xml><?xml version="1.0" encoding="utf-8"?>
+<p:properties xmlns:p="http://schemas.microsoft.com/office/2006/metadata/properties" xmlns:xsi="http://www.w3.org/2001/XMLSchema-instance" xmlns:pc="http://schemas.microsoft.com/office/infopath/2007/PartnerControls">
+  <documentManagement>
+    <TaxCatchAll xmlns="90685ef0-b1b4-458c-829f-f398f8759114" xsi:nil="true"/>
+    <lcf76f155ced4ddcb4097134ff3c332f xmlns="642e82f0-cb46-4fb4-8075-6238c0cf1caf">
+      <Terms xmlns="http://schemas.microsoft.com/office/infopath/2007/PartnerControls"/>
+    </lcf76f155ced4ddcb4097134ff3c332f>
+  </documentManagement>
+</p:properties>
+</file>
+
+<file path=customXml/item3.xml><?xml version="1.0" encoding="utf-8"?>
 <ct:contentTypeSchema xmlns:ct="http://schemas.microsoft.com/office/2006/metadata/contentType" xmlns:ma="http://schemas.microsoft.com/office/2006/metadata/properties/metaAttributes" ct:_="" ma:_="" ma:contentTypeName="Document" ma:contentTypeID="0x0101009EC9433B644E604094407ACD1E5072B8" ma:contentTypeVersion="11" ma:contentTypeDescription="Create a new document." ma:contentTypeScope="" ma:versionID="3d1b3dfc843b4f81bcd91a66cd11289c">
   <xsd:schema xmlns:xsd="http://www.w3.org/2001/XMLSchema" xmlns:xs="http://www.w3.org/2001/XMLSchema" xmlns:p="http://schemas.microsoft.com/office/2006/metadata/properties" xmlns:ns2="642e82f0-cb46-4fb4-8075-6238c0cf1caf" xmlns:ns3="90685ef0-b1b4-458c-829f-f398f8759114" targetNamespace="http://schemas.microsoft.com/office/2006/metadata/properties" ma:root="true" ma:fieldsID="c2c5bc462af54d3217fc1b623fd434e4" ns2:_="" ns3:_="">
     <xsd:import namespace="642e82f0-cb46-4fb4-8075-6238c0cf1caf"/>
@@ -8967,17 +9162,6 @@
 </ct:contentTypeSchema>
 </file>
 
-<file path=customXml/item3.xml><?xml version="1.0" encoding="utf-8"?>
-<p:properties xmlns:p="http://schemas.microsoft.com/office/2006/metadata/properties" xmlns:xsi="http://www.w3.org/2001/XMLSchema-instance" xmlns:pc="http://schemas.microsoft.com/office/infopath/2007/PartnerControls">
-  <documentManagement>
-    <TaxCatchAll xmlns="90685ef0-b1b4-458c-829f-f398f8759114" xsi:nil="true"/>
-    <lcf76f155ced4ddcb4097134ff3c332f xmlns="642e82f0-cb46-4fb4-8075-6238c0cf1caf">
-      <Terms xmlns="http://schemas.microsoft.com/office/infopath/2007/PartnerControls"/>
-    </lcf76f155ced4ddcb4097134ff3c332f>
-  </documentManagement>
-</p:properties>
-</file>
-
 <file path=customXml/itemProps1.xml><?xml version="1.0" encoding="utf-8"?>
 <ds:datastoreItem xmlns:ds="http://schemas.openxmlformats.org/officeDocument/2006/customXml" ds:itemID="{F8CF3EDC-8FD0-4596-81B6-38CE81E1E856}">
   <ds:schemaRefs>
@@ -8987,6 +9171,19 @@
 </file>
 
 <file path=customXml/itemProps2.xml><?xml version="1.0" encoding="utf-8"?>
+<ds:datastoreItem xmlns:ds="http://schemas.openxmlformats.org/officeDocument/2006/customXml" ds:itemID="{788B5E7D-9C02-44FA-96B3-2BC0EDBB49E2}">
+  <ds:schemaRefs>
+    <ds:schemaRef ds:uri="http://schemas.microsoft.com/office/2006/metadata/properties"/>
+    <ds:schemaRef ds:uri="http://schemas.microsoft.com/office/infopath/2007/PartnerControls"/>
+    <ds:schemaRef ds:uri="30d97937-01a3-4de3-90ca-5e7d330c9e3c"/>
+    <ds:schemaRef ds:uri="9424389c-3462-41f7-a219-8f9753f44d22"/>
+    <ds:schemaRef ds:uri="90685ef0-b1b4-458c-829f-f398f8759114"/>
+    <ds:schemaRef ds:uri="642e82f0-cb46-4fb4-8075-6238c0cf1caf"/>
+  </ds:schemaRefs>
+</ds:datastoreItem>
+</file>
+
+<file path=customXml/itemProps3.xml><?xml version="1.0" encoding="utf-8"?>
 <ds:datastoreItem xmlns:ds="http://schemas.openxmlformats.org/officeDocument/2006/customXml" ds:itemID="{3298221C-B78A-47B7-BF46-B98F710577AA}">
   <ds:schemaRefs>
     <ds:schemaRef ds:uri="http://schemas.microsoft.com/office/2006/metadata/contentType"/>
@@ -9003,17 +9200,4 @@
     <ds:schemaRef ds:uri="http://schemas.microsoft.com/internal/obd"/>
   </ds:schemaRefs>
 </ds:datastoreItem>
-</file>
-
-<file path=customXml/itemProps3.xml><?xml version="1.0" encoding="utf-8"?>
-<ds:datastoreItem xmlns:ds="http://schemas.openxmlformats.org/officeDocument/2006/customXml" ds:itemID="{788B5E7D-9C02-44FA-96B3-2BC0EDBB49E2}">
-  <ds:schemaRefs>
-    <ds:schemaRef ds:uri="http://schemas.microsoft.com/office/2006/metadata/properties"/>
-    <ds:schemaRef ds:uri="http://schemas.microsoft.com/office/infopath/2007/PartnerControls"/>
-    <ds:schemaRef ds:uri="30d97937-01a3-4de3-90ca-5e7d330c9e3c"/>
-    <ds:schemaRef ds:uri="9424389c-3462-41f7-a219-8f9753f44d22"/>
-    <ds:schemaRef ds:uri="90685ef0-b1b4-458c-829f-f398f8759114"/>
-    <ds:schemaRef ds:uri="642e82f0-cb46-4fb4-8075-6238c0cf1caf"/>
-  </ds:schemaRefs>
-</ds:datastoreItem>
 </file>
</xml_diff>